<commit_message>
Highlight civic groups court evidence gap in final pitch
</commit_message>
<xml_diff>
--- a/docs/hackathon/Pune-Fast-Complaint-Final-Pitch.pptx
+++ b/docs/hackathon/Pune-Fast-Complaint-Final-Pitch.pptx
@@ -2,16 +2,16 @@
 <file path=ppt/presentation.xml><?xml version="1.0" encoding="utf-8"?>
 <p:presentation xmlns:p="http://schemas.openxmlformats.org/presentationml/2006/main">
   <p:sldMasterIdLst>
-    <p:sldMasterId xmlns:r="http://schemas.openxmlformats.org/officeDocument/2006/relationships" id="2147483648" r:id="Rc380f6c00bef4f32"/>
+    <p:sldMasterId xmlns:r="http://schemas.openxmlformats.org/officeDocument/2006/relationships" id="2147483648" r:id="Rbbeeca2b00c045b3"/>
   </p:sldMasterIdLst>
   <p:notesMasterIdLst>
-    <p:notesMasterId xmlns:r="http://schemas.openxmlformats.org/officeDocument/2006/relationships" r:id="R0444e47782334882"/>
+    <p:notesMasterId xmlns:r="http://schemas.openxmlformats.org/officeDocument/2006/relationships" r:id="R3da278e8cb144458"/>
   </p:notesMasterIdLst>
   <p:sldIdLst>
-    <p:sldId xmlns:r="http://schemas.openxmlformats.org/officeDocument/2006/relationships" id="256" r:id="R4d8ee876f8ed40cd"/>
-    <p:sldId xmlns:r="http://schemas.openxmlformats.org/officeDocument/2006/relationships" id="257" r:id="Rf6ddacd5a4d74d1d"/>
-    <p:sldId xmlns:r="http://schemas.openxmlformats.org/officeDocument/2006/relationships" id="258" r:id="R9e560ec28dda4137"/>
-    <p:sldId xmlns:r="http://schemas.openxmlformats.org/officeDocument/2006/relationships" id="259" r:id="R8930c0bebf37496a"/>
+    <p:sldId xmlns:r="http://schemas.openxmlformats.org/officeDocument/2006/relationships" id="256" r:id="R7f5a88f4adbd4209"/>
+    <p:sldId xmlns:r="http://schemas.openxmlformats.org/officeDocument/2006/relationships" id="257" r:id="R54c6ac67109c430c"/>
+    <p:sldId xmlns:r="http://schemas.openxmlformats.org/officeDocument/2006/relationships" id="258" r:id="R1816dcddaadd4bc9"/>
+    <p:sldId xmlns:r="http://schemas.openxmlformats.org/officeDocument/2006/relationships" id="259" r:id="Red70a07f92014738"/>
   </p:sldIdLst>
   <p:sldSz cx="12192000" cy="6858000"/>
   <p:notesSz cx="6858000" cy="9144000"/>
@@ -675,7 +675,7 @@
           <a:lstStyle xmlns:a="http://schemas.openxmlformats.org/drawingml/2006/main"/>
           <a:p xmlns:a="http://schemas.openxmlformats.org/drawingml/2006/main">
             <a:r>
-              <a:t>TIMING: 3:30–4:00 (30 seconds), immediately after returning from the app demo.</a:t>
+              <a:t>TIMING: 3:30–4:00 (30 seconds), immediately after the app demo.</a:t>
             </a:r>
           </a:p>
           <a:p xmlns:a="http://schemas.openxmlformats.org/drawingml/2006/main">
@@ -690,7 +690,7 @@
           </a:p>
           <a:p xmlns:a="http://schemas.openxmlformats.org/drawingml/2006/main">
             <a:r>
-              <a:t>What you just saw is the citizen journey. Filing creates a documented complaint. The public map gives it visibility. For supported cases, a follow-up photograph helps show whether the physical problem changed. If it remains unresolved, the citizen has an organised record to support further escalation.</a:t>
+              <a:t>There is a second problem: civic organisations may know an issue persists, but lack organised evidence to support a case in court. Citizen photographs, complaint records and follow-up evidence can help substantiate those concerns. With legal review, groups can use supporting records in proceedings to seek action and hold authorities accountable. Court acceptance still depends on evidentiary requirements.</a:t>
             </a:r>
           </a:p>
           <a:p xmlns:a="http://schemas.openxmlformats.org/drawingml/2006/main">
@@ -700,7 +700,7 @@
           </a:p>
           <a:p xmlns:a="http://schemas.openxmlformats.org/drawingml/2006/main">
             <a:r>
-              <a:t>SOURCE: useComplaintFlow.ts, complaint screens, server complaint and verification handlers. Follow-up photo verification applies only to supported cases. These records do not prove official acknowledgement or legal liability. This is a user-flow architecture diagram, deliberately without the technology stack.</a:t>
+              <a:t>SOURCE: Problem statement and civic organisation use case supplied by the project team. The app collects evidence and complaint records. This slide describes how civic groups could use those records, not an implemented legal case-management or organisation-access feature. No guaranteed admissibility, court outcome, legal liability or certified chain of custody is claimed.</a:t>
             </a:r>
           </a:p>
         </p:txBody>
@@ -857,7 +857,7 @@
           <p:cNvPr id="3" name="Title">
             <a:extLst xmlns:a="http://schemas.openxmlformats.org/drawingml/2006/main">
               <a:ext uri="{FF2B5EF4-FFF2-40B4-BE49-F238E27FC236}">
-                <a16:creationId xmlns:a16="http://schemas.microsoft.com/office/drawing/2014/main" id="{0D6D6564-158B-4584-9C5E-F3FC5274EDB6}"/>
+                <a16:creationId xmlns:a16="http://schemas.microsoft.com/office/drawing/2014/main" id="{25DB5F6F-EE4E-4582-B059-B9F9AA5D3719}"/>
               </a:ext>
             </a:extLst>
           </p:cNvPr>
@@ -1014,7 +1014,7 @@
           <p:cNvPr id="2" name="Subtitle">
             <a:extLst xmlns:a="http://schemas.openxmlformats.org/drawingml/2006/main">
               <a:ext uri="{FF2B5EF4-FFF2-40B4-BE49-F238E27FC236}">
-                <a16:creationId xmlns:a16="http://schemas.microsoft.com/office/drawing/2014/main" id="{0CDD4693-24C1-44D1-93B3-94FB92B12E07}"/>
+                <a16:creationId xmlns:a16="http://schemas.microsoft.com/office/drawing/2014/main" id="{1513E8B5-7FA7-453B-B468-2B6542EE600C}"/>
               </a:ext>
             </a:extLst>
           </p:cNvPr>
@@ -1188,7 +1188,7 @@
           <p:cNvPr id="2" name="Section title">
             <a:extLst xmlns:a="http://schemas.openxmlformats.org/drawingml/2006/main">
               <a:ext uri="{FF2B5EF4-FFF2-40B4-BE49-F238E27FC236}">
-                <a16:creationId xmlns:a16="http://schemas.microsoft.com/office/drawing/2014/main" id="{561D9B0E-852D-435B-97CA-5088E37081F7}"/>
+                <a16:creationId xmlns:a16="http://schemas.microsoft.com/office/drawing/2014/main" id="{D0F42CB3-D3DD-46AD-A8BC-6BD203FAB348}"/>
               </a:ext>
             </a:extLst>
           </p:cNvPr>
@@ -1362,7 +1362,7 @@
           <p:cNvPr id="3" name="Title">
             <a:extLst xmlns:a="http://schemas.openxmlformats.org/drawingml/2006/main">
               <a:ext uri="{FF2B5EF4-FFF2-40B4-BE49-F238E27FC236}">
-                <a16:creationId xmlns:a16="http://schemas.microsoft.com/office/drawing/2014/main" id="{7316EA64-6E57-4E4D-9C34-9D2F2C0FB0D4}"/>
+                <a16:creationId xmlns:a16="http://schemas.microsoft.com/office/drawing/2014/main" id="{98860C49-917F-4DA1-AF60-0BC1DCF24CF9}"/>
               </a:ext>
             </a:extLst>
           </p:cNvPr>
@@ -1519,7 +1519,7 @@
           <p:cNvPr id="2" name="Body">
             <a:extLst xmlns:a="http://schemas.openxmlformats.org/drawingml/2006/main">
               <a:ext uri="{FF2B5EF4-FFF2-40B4-BE49-F238E27FC236}">
-                <a16:creationId xmlns:a16="http://schemas.microsoft.com/office/drawing/2014/main" id="{583A48FF-7EE9-4542-8F64-0BCD59FB29A0}"/>
+                <a16:creationId xmlns:a16="http://schemas.microsoft.com/office/drawing/2014/main" id="{D3EA38C1-1E4E-420D-9351-573AAF0110CC}"/>
               </a:ext>
             </a:extLst>
           </p:cNvPr>
@@ -1693,7 +1693,7 @@
           <p:cNvPr id="4" name="Title">
             <a:extLst xmlns:a="http://schemas.openxmlformats.org/drawingml/2006/main">
               <a:ext uri="{FF2B5EF4-FFF2-40B4-BE49-F238E27FC236}">
-                <a16:creationId xmlns:a16="http://schemas.microsoft.com/office/drawing/2014/main" id="{C72B2DFE-8C4E-4163-961B-10953ACBDCCE}"/>
+                <a16:creationId xmlns:a16="http://schemas.microsoft.com/office/drawing/2014/main" id="{D30AB516-AD67-4B84-B758-D98F384AC25C}"/>
               </a:ext>
             </a:extLst>
           </p:cNvPr>
@@ -1850,7 +1850,7 @@
           <p:cNvPr id="2" name="Left column">
             <a:extLst xmlns:a="http://schemas.openxmlformats.org/drawingml/2006/main">
               <a:ext uri="{FF2B5EF4-FFF2-40B4-BE49-F238E27FC236}">
-                <a16:creationId xmlns:a16="http://schemas.microsoft.com/office/drawing/2014/main" id="{63DBC81D-28C0-435E-9209-FFA560D5A7D3}"/>
+                <a16:creationId xmlns:a16="http://schemas.microsoft.com/office/drawing/2014/main" id="{68D93413-1CE8-4C8E-A4D6-7262C2D087C2}"/>
               </a:ext>
             </a:extLst>
           </p:cNvPr>
@@ -2007,7 +2007,7 @@
           <p:cNvPr id="3" name="Right column">
             <a:extLst xmlns:a="http://schemas.openxmlformats.org/drawingml/2006/main">
               <a:ext uri="{FF2B5EF4-FFF2-40B4-BE49-F238E27FC236}">
-                <a16:creationId xmlns:a16="http://schemas.microsoft.com/office/drawing/2014/main" id="{E7153A15-CA90-4E71-81FF-1D94AAF626A1}"/>
+                <a16:creationId xmlns:a16="http://schemas.microsoft.com/office/drawing/2014/main" id="{93EA8D4C-47A2-4820-B5E7-9957814E2071}"/>
               </a:ext>
             </a:extLst>
           </p:cNvPr>
@@ -2181,7 +2181,7 @@
           <p:cNvPr id="3" name="Title">
             <a:extLst xmlns:a="http://schemas.openxmlformats.org/drawingml/2006/main">
               <a:ext uri="{FF2B5EF4-FFF2-40B4-BE49-F238E27FC236}">
-                <a16:creationId xmlns:a16="http://schemas.microsoft.com/office/drawing/2014/main" id="{CEEEDC28-3343-4A7F-AD1D-F13FBE2E661B}"/>
+                <a16:creationId xmlns:a16="http://schemas.microsoft.com/office/drawing/2014/main" id="{0795753B-01ED-4871-9ED3-3D30C1BC49FE}"/>
               </a:ext>
             </a:extLst>
           </p:cNvPr>
@@ -2338,7 +2338,7 @@
           <p:cNvPr id="2" name="Left column">
             <a:extLst xmlns:a="http://schemas.openxmlformats.org/drawingml/2006/main">
               <a:ext uri="{FF2B5EF4-FFF2-40B4-BE49-F238E27FC236}">
-                <a16:creationId xmlns:a16="http://schemas.microsoft.com/office/drawing/2014/main" id="{8F2A172E-085D-4A69-8BBD-92FCFFBE22D7}"/>
+                <a16:creationId xmlns:a16="http://schemas.microsoft.com/office/drawing/2014/main" id="{6CE63065-8752-4757-B198-06C011D937B1}"/>
               </a:ext>
             </a:extLst>
           </p:cNvPr>
@@ -2533,12 +2533,12 @@
   </p:cSld>
   <p:clrMap bg1="lt1" tx1="dk1" bg2="lt2" tx2="dk2" accent1="accent1" accent2="accent2" accent3="accent3" accent4="accent4" accent5="accent5" accent6="accent6" hlink="hlink" folHlink="folHlink"/>
   <p:sldLayoutIdLst>
-    <p:sldLayoutId xmlns:r="http://schemas.openxmlformats.org/officeDocument/2006/relationships" id="2147483649" r:id="Rb93f4d5da3884d22"/>
-    <p:sldLayoutId xmlns:r="http://schemas.openxmlformats.org/officeDocument/2006/relationships" id="2147483650" r:id="R043796945c234a5d"/>
-    <p:sldLayoutId xmlns:r="http://schemas.openxmlformats.org/officeDocument/2006/relationships" id="2147483651" r:id="R0403814f827f4698"/>
-    <p:sldLayoutId xmlns:r="http://schemas.openxmlformats.org/officeDocument/2006/relationships" id="2147483652" r:id="R419f886d411342ff"/>
-    <p:sldLayoutId xmlns:r="http://schemas.openxmlformats.org/officeDocument/2006/relationships" id="2147483653" r:id="R36aef603897043a0"/>
-    <p:sldLayoutId xmlns:r="http://schemas.openxmlformats.org/officeDocument/2006/relationships" id="2147483654" r:id="R3acf40224b6145f2"/>
+    <p:sldLayoutId xmlns:r="http://schemas.openxmlformats.org/officeDocument/2006/relationships" id="2147483649" r:id="R01e90702db1f47e0"/>
+    <p:sldLayoutId xmlns:r="http://schemas.openxmlformats.org/officeDocument/2006/relationships" id="2147483650" r:id="R79579a83901848d6"/>
+    <p:sldLayoutId xmlns:r="http://schemas.openxmlformats.org/officeDocument/2006/relationships" id="2147483651" r:id="Rca3c72f46c624089"/>
+    <p:sldLayoutId xmlns:r="http://schemas.openxmlformats.org/officeDocument/2006/relationships" id="2147483652" r:id="R98d21ec82bd44927"/>
+    <p:sldLayoutId xmlns:r="http://schemas.openxmlformats.org/officeDocument/2006/relationships" id="2147483653" r:id="Rae65e3c5cfd84e43"/>
+    <p:sldLayoutId xmlns:r="http://schemas.openxmlformats.org/officeDocument/2006/relationships" id="2147483654" r:id="Rbbce5d175e2c4a9c"/>
   </p:sldLayoutIdLst>
   <p:txStyles>
     <p:titleStyle>
@@ -3089,7 +3089,7 @@
           <p:cNvPr id="9" name="text-1">
             <a:extLst xmlns:a="http://schemas.openxmlformats.org/drawingml/2006/main">
               <a:ext uri="{FF2B5EF4-FFF2-40B4-BE49-F238E27FC236}">
-                <a16:creationId xmlns:a16="http://schemas.microsoft.com/office/drawing/2014/main" id="{D4E628D8-D145-4553-80D0-BC60B3410F3D}"/>
+                <a16:creationId xmlns:a16="http://schemas.microsoft.com/office/drawing/2014/main" id="{0546FE6E-9F5D-4CE3-94A6-4822C8F8A99A}"/>
               </a:ext>
             </a:extLst>
           </p:cNvPr>
@@ -3157,7 +3157,7 @@
           <p:cNvPr id="2" name="text-2">
             <a:extLst xmlns:a="http://schemas.openxmlformats.org/drawingml/2006/main">
               <a:ext uri="{FF2B5EF4-FFF2-40B4-BE49-F238E27FC236}">
-                <a16:creationId xmlns:a16="http://schemas.microsoft.com/office/drawing/2014/main" id="{AA355A11-606F-4E72-9C63-82DBAED13B69}"/>
+                <a16:creationId xmlns:a16="http://schemas.microsoft.com/office/drawing/2014/main" id="{1EA56ABB-50C1-442F-BC1C-6A2DF195531B}"/>
               </a:ext>
             </a:extLst>
           </p:cNvPr>
@@ -3248,7 +3248,7 @@
           <p:cNvPr id="3" name="text-3">
             <a:extLst xmlns:a="http://schemas.openxmlformats.org/drawingml/2006/main">
               <a:ext uri="{FF2B5EF4-FFF2-40B4-BE49-F238E27FC236}">
-                <a16:creationId xmlns:a16="http://schemas.microsoft.com/office/drawing/2014/main" id="{9E2D5A6B-29E5-42B9-BFEC-A4426E458E6D}"/>
+                <a16:creationId xmlns:a16="http://schemas.microsoft.com/office/drawing/2014/main" id="{BD0E56D8-CBD0-4CAD-9643-457EC828292A}"/>
               </a:ext>
             </a:extLst>
           </p:cNvPr>
@@ -3339,7 +3339,7 @@
           <p:cNvPr id="4" name="text-4">
             <a:extLst xmlns:a="http://schemas.openxmlformats.org/drawingml/2006/main">
               <a:ext uri="{FF2B5EF4-FFF2-40B4-BE49-F238E27FC236}">
-                <a16:creationId xmlns:a16="http://schemas.microsoft.com/office/drawing/2014/main" id="{6EADB179-6C78-4C5E-8475-F3311B4C8A1D}"/>
+                <a16:creationId xmlns:a16="http://schemas.microsoft.com/office/drawing/2014/main" id="{9FC5FFA3-7886-4298-8672-9933FC339872}"/>
               </a:ext>
             </a:extLst>
           </p:cNvPr>
@@ -3430,7 +3430,7 @@
           <p:cNvPr id="5" name="">
             <a:extLst xmlns:a="http://schemas.openxmlformats.org/drawingml/2006/main">
               <a:ext uri="{FF2B5EF4-FFF2-40B4-BE49-F238E27FC236}">
-                <a16:creationId xmlns:a16="http://schemas.microsoft.com/office/drawing/2014/main" id="{90FE88B8-BCB0-47F5-8ED8-7A08FEC37437}"/>
+                <a16:creationId xmlns:a16="http://schemas.microsoft.com/office/drawing/2014/main" id="{596E4544-E7B2-4635-8A86-C2B57A6936E6}"/>
               </a:ext>
             </a:extLst>
           </p:cNvPr>
@@ -3440,7 +3440,7 @@
           <p:nvPr/>
         </p:nvPicPr>
         <p:blipFill>
-          <a:blip xmlns:r="http://schemas.openxmlformats.org/officeDocument/2006/relationships" xmlns:a="http://schemas.openxmlformats.org/drawingml/2006/main" r:embed="Rbfae9288971a467d"/>
+          <a:blip xmlns:r="http://schemas.openxmlformats.org/officeDocument/2006/relationships" xmlns:a="http://schemas.openxmlformats.org/drawingml/2006/main" r:embed="R66ef06f197b444bb"/>
           <a:stretch xmlns:a="http://schemas.openxmlformats.org/drawingml/2006/main"/>
         </p:blipFill>
         <p:spPr>
@@ -3458,7 +3458,7 @@
           <p:cNvPr id="6" name="frame-5">
             <a:extLst xmlns:a="http://schemas.openxmlformats.org/drawingml/2006/main">
               <a:ext uri="{FF2B5EF4-FFF2-40B4-BE49-F238E27FC236}">
-                <a16:creationId xmlns:a16="http://schemas.microsoft.com/office/drawing/2014/main" id="{FE224613-206A-4243-BB83-320393A3EDA1}"/>
+                <a16:creationId xmlns:a16="http://schemas.microsoft.com/office/drawing/2014/main" id="{FCD898E9-640F-4EC1-A74A-754AB8E6F9F1}"/>
               </a:ext>
             </a:extLst>
           </p:cNvPr>
@@ -3488,7 +3488,7 @@
           <p:cNvPr id="7" name="text-6">
             <a:extLst xmlns:a="http://schemas.openxmlformats.org/drawingml/2006/main">
               <a:ext uri="{FF2B5EF4-FFF2-40B4-BE49-F238E27FC236}">
-                <a16:creationId xmlns:a16="http://schemas.microsoft.com/office/drawing/2014/main" id="{4D27CC68-AB5A-4434-B133-61A8C5F82D8B}"/>
+                <a16:creationId xmlns:a16="http://schemas.microsoft.com/office/drawing/2014/main" id="{696B290D-948A-4FD4-BC7A-1C2422DDB1A0}"/>
               </a:ext>
             </a:extLst>
           </p:cNvPr>
@@ -3556,7 +3556,7 @@
           <p:cNvPr id="8" name="text-7">
             <a:extLst xmlns:a="http://schemas.openxmlformats.org/drawingml/2006/main">
               <a:ext uri="{FF2B5EF4-FFF2-40B4-BE49-F238E27FC236}">
-                <a16:creationId xmlns:a16="http://schemas.microsoft.com/office/drawing/2014/main" id="{52E70701-AE90-4E10-8826-2B192895ECAE}"/>
+                <a16:creationId xmlns:a16="http://schemas.microsoft.com/office/drawing/2014/main" id="{BF144E06-F82D-40F6-9C99-FBF22B86DCF0}"/>
               </a:ext>
             </a:extLst>
           </p:cNvPr>
@@ -3622,7 +3622,7 @@
     </p:spTree>
     <p:extLst>
       <p:ext uri="{BB962C8B-B14F-4D97-AF65-F5344CB8AC3E}">
-        <p14:creationId xmlns:p14="http://schemas.microsoft.com/office/powerpoint/2010/main" val="1311839425"/>
+        <p14:creationId xmlns:p14="http://schemas.microsoft.com/office/powerpoint/2010/main" val="1615131332"/>
       </p:ext>
     </p:extLst>
   </p:cSld>
@@ -3653,7 +3653,7 @@
           <p:cNvPr id="19" name="text-8">
             <a:extLst xmlns:a="http://schemas.openxmlformats.org/drawingml/2006/main">
               <a:ext uri="{FF2B5EF4-FFF2-40B4-BE49-F238E27FC236}">
-                <a16:creationId xmlns:a16="http://schemas.microsoft.com/office/drawing/2014/main" id="{4FE2817B-16EE-41DA-8A81-8F4C58B5C4FE}"/>
+                <a16:creationId xmlns:a16="http://schemas.microsoft.com/office/drawing/2014/main" id="{5ABDE5AB-FC33-48C5-AF15-20FED71806E9}"/>
               </a:ext>
             </a:extLst>
           </p:cNvPr>
@@ -3721,7 +3721,7 @@
           <p:cNvPr id="2" name="text-9">
             <a:extLst xmlns:a="http://schemas.openxmlformats.org/drawingml/2006/main">
               <a:ext uri="{FF2B5EF4-FFF2-40B4-BE49-F238E27FC236}">
-                <a16:creationId xmlns:a16="http://schemas.microsoft.com/office/drawing/2014/main" id="{26739069-BC27-4967-A340-24DAD07B396E}"/>
+                <a16:creationId xmlns:a16="http://schemas.microsoft.com/office/drawing/2014/main" id="{A9394D7A-97E6-42D0-9E5C-BBBE4A9F91C1}"/>
               </a:ext>
             </a:extLst>
           </p:cNvPr>
@@ -3789,7 +3789,7 @@
           <p:cNvPr id="3" name="frame-10">
             <a:extLst xmlns:a="http://schemas.openxmlformats.org/drawingml/2006/main">
               <a:ext uri="{FF2B5EF4-FFF2-40B4-BE49-F238E27FC236}">
-                <a16:creationId xmlns:a16="http://schemas.microsoft.com/office/drawing/2014/main" id="{2254B53F-4928-48DA-BB7F-F83D5723AC5D}"/>
+                <a16:creationId xmlns:a16="http://schemas.microsoft.com/office/drawing/2014/main" id="{984D17BB-2DD0-4F60-91E8-3C1737E23C4F}"/>
               </a:ext>
             </a:extLst>
           </p:cNvPr>
@@ -3819,7 +3819,7 @@
           <p:cNvPr id="4" name="text-11">
             <a:extLst xmlns:a="http://schemas.openxmlformats.org/drawingml/2006/main">
               <a:ext uri="{FF2B5EF4-FFF2-40B4-BE49-F238E27FC236}">
-                <a16:creationId xmlns:a16="http://schemas.microsoft.com/office/drawing/2014/main" id="{101A280F-194C-478B-8D61-28EFA66025EA}"/>
+                <a16:creationId xmlns:a16="http://schemas.microsoft.com/office/drawing/2014/main" id="{9B14192D-4745-4C08-B680-65E2C533BA96}"/>
               </a:ext>
             </a:extLst>
           </p:cNvPr>
@@ -3887,7 +3887,7 @@
           <p:cNvPr id="5" name="text-12">
             <a:extLst xmlns:a="http://schemas.openxmlformats.org/drawingml/2006/main">
               <a:ext uri="{FF2B5EF4-FFF2-40B4-BE49-F238E27FC236}">
-                <a16:creationId xmlns:a16="http://schemas.microsoft.com/office/drawing/2014/main" id="{EE6B1DC6-0B61-4515-AC7C-3F79766AF570}"/>
+                <a16:creationId xmlns:a16="http://schemas.microsoft.com/office/drawing/2014/main" id="{65999EA9-826B-4A81-A33C-0DBC6B8CC157}"/>
               </a:ext>
             </a:extLst>
           </p:cNvPr>
@@ -3955,7 +3955,7 @@
           <p:cNvPr id="6" name="text-13">
             <a:extLst xmlns:a="http://schemas.openxmlformats.org/drawingml/2006/main">
               <a:ext uri="{FF2B5EF4-FFF2-40B4-BE49-F238E27FC236}">
-                <a16:creationId xmlns:a16="http://schemas.microsoft.com/office/drawing/2014/main" id="{8BDEA1F3-AC95-4FF6-845C-1C2075382D90}"/>
+                <a16:creationId xmlns:a16="http://schemas.microsoft.com/office/drawing/2014/main" id="{85A1E5EC-5DD9-4F14-90C1-F789DBF0F70E}"/>
               </a:ext>
             </a:extLst>
           </p:cNvPr>
@@ -4023,7 +4023,7 @@
           <p:cNvPr id="7" name="text-14">
             <a:extLst xmlns:a="http://schemas.openxmlformats.org/drawingml/2006/main">
               <a:ext uri="{FF2B5EF4-FFF2-40B4-BE49-F238E27FC236}">
-                <a16:creationId xmlns:a16="http://schemas.microsoft.com/office/drawing/2014/main" id="{CF056103-732D-4051-BE2D-5A3DD942A847}"/>
+                <a16:creationId xmlns:a16="http://schemas.microsoft.com/office/drawing/2014/main" id="{23D81A3D-9A5F-44B6-B178-37DEF3F246F8}"/>
               </a:ext>
             </a:extLst>
           </p:cNvPr>
@@ -4091,7 +4091,7 @@
           <p:cNvPr id="8" name="text-15">
             <a:extLst xmlns:a="http://schemas.openxmlformats.org/drawingml/2006/main">
               <a:ext uri="{FF2B5EF4-FFF2-40B4-BE49-F238E27FC236}">
-                <a16:creationId xmlns:a16="http://schemas.microsoft.com/office/drawing/2014/main" id="{F4A7E19A-474B-4669-9995-FF5347212A69}"/>
+                <a16:creationId xmlns:a16="http://schemas.microsoft.com/office/drawing/2014/main" id="{0ADDD58E-8B89-4AB9-8366-BD9D8E920A08}"/>
               </a:ext>
             </a:extLst>
           </p:cNvPr>
@@ -4205,7 +4205,7 @@
           <p:cNvPr id="9" name="text-16">
             <a:extLst xmlns:a="http://schemas.openxmlformats.org/drawingml/2006/main">
               <a:ext uri="{FF2B5EF4-FFF2-40B4-BE49-F238E27FC236}">
-                <a16:creationId xmlns:a16="http://schemas.microsoft.com/office/drawing/2014/main" id="{9443C472-CAD5-4741-A02A-8E8C67435FBE}"/>
+                <a16:creationId xmlns:a16="http://schemas.microsoft.com/office/drawing/2014/main" id="{884CE969-6D94-4EFC-9EBA-85D68ECF86C7}"/>
               </a:ext>
             </a:extLst>
           </p:cNvPr>
@@ -4273,7 +4273,7 @@
           <p:cNvPr id="10" name="text-17">
             <a:extLst xmlns:a="http://schemas.openxmlformats.org/drawingml/2006/main">
               <a:ext uri="{FF2B5EF4-FFF2-40B4-BE49-F238E27FC236}">
-                <a16:creationId xmlns:a16="http://schemas.microsoft.com/office/drawing/2014/main" id="{587F104C-716B-4384-9F0D-28D52B07676D}"/>
+                <a16:creationId xmlns:a16="http://schemas.microsoft.com/office/drawing/2014/main" id="{20F4F09C-6B09-485F-A45F-3839A358F429}"/>
               </a:ext>
             </a:extLst>
           </p:cNvPr>
@@ -4341,7 +4341,7 @@
           <p:cNvPr id="11" name="text-18">
             <a:extLst xmlns:a="http://schemas.openxmlformats.org/drawingml/2006/main">
               <a:ext uri="{FF2B5EF4-FFF2-40B4-BE49-F238E27FC236}">
-                <a16:creationId xmlns:a16="http://schemas.microsoft.com/office/drawing/2014/main" id="{3026A244-DDE4-451F-8195-EB2AB1872615}"/>
+                <a16:creationId xmlns:a16="http://schemas.microsoft.com/office/drawing/2014/main" id="{35F70011-820D-42B1-A0C0-7C2DAA5C416B}"/>
               </a:ext>
             </a:extLst>
           </p:cNvPr>
@@ -4409,7 +4409,7 @@
           <p:cNvPr id="12" name="text-19">
             <a:extLst xmlns:a="http://schemas.openxmlformats.org/drawingml/2006/main">
               <a:ext uri="{FF2B5EF4-FFF2-40B4-BE49-F238E27FC236}">
-                <a16:creationId xmlns:a16="http://schemas.microsoft.com/office/drawing/2014/main" id="{5CF871AD-FDA9-404C-9C61-B6B8094FFA7D}"/>
+                <a16:creationId xmlns:a16="http://schemas.microsoft.com/office/drawing/2014/main" id="{CA5171E6-5A1B-4697-BDA9-982CEAE7C669}"/>
               </a:ext>
             </a:extLst>
           </p:cNvPr>
@@ -4546,7 +4546,7 @@
           <p:cNvPr id="13" name="text-20">
             <a:extLst xmlns:a="http://schemas.openxmlformats.org/drawingml/2006/main">
               <a:ext uri="{FF2B5EF4-FFF2-40B4-BE49-F238E27FC236}">
-                <a16:creationId xmlns:a16="http://schemas.microsoft.com/office/drawing/2014/main" id="{D05AD19D-740E-4376-A63E-8B5D7F7D2ED4}"/>
+                <a16:creationId xmlns:a16="http://schemas.microsoft.com/office/drawing/2014/main" id="{94EFBED6-EEBC-49D7-9861-52BBE4BB82D8}"/>
               </a:ext>
             </a:extLst>
           </p:cNvPr>
@@ -4614,7 +4614,7 @@
           <p:cNvPr id="14" name="text-21">
             <a:extLst xmlns:a="http://schemas.openxmlformats.org/drawingml/2006/main">
               <a:ext uri="{FF2B5EF4-FFF2-40B4-BE49-F238E27FC236}">
-                <a16:creationId xmlns:a16="http://schemas.microsoft.com/office/drawing/2014/main" id="{E69E4389-EB8F-4C6A-B524-EC8234B2C385}"/>
+                <a16:creationId xmlns:a16="http://schemas.microsoft.com/office/drawing/2014/main" id="{8BBC4D0D-CCB2-4FCB-B342-0F9AFA1A7294}"/>
               </a:ext>
             </a:extLst>
           </p:cNvPr>
@@ -4682,7 +4682,7 @@
           <p:cNvPr id="15" name="text-22">
             <a:extLst xmlns:a="http://schemas.openxmlformats.org/drawingml/2006/main">
               <a:ext uri="{FF2B5EF4-FFF2-40B4-BE49-F238E27FC236}">
-                <a16:creationId xmlns:a16="http://schemas.microsoft.com/office/drawing/2014/main" id="{54E96D92-78A9-407E-B3DA-0DEBFDA1A97B}"/>
+                <a16:creationId xmlns:a16="http://schemas.microsoft.com/office/drawing/2014/main" id="{A7E82D08-D732-49D0-B5D9-D729E148B2D2}"/>
               </a:ext>
             </a:extLst>
           </p:cNvPr>
@@ -4750,7 +4750,7 @@
           <p:cNvPr id="16" name="text-23">
             <a:extLst xmlns:a="http://schemas.openxmlformats.org/drawingml/2006/main">
               <a:ext uri="{FF2B5EF4-FFF2-40B4-BE49-F238E27FC236}">
-                <a16:creationId xmlns:a16="http://schemas.microsoft.com/office/drawing/2014/main" id="{343272D1-AFED-4F08-BB3C-18E2B4A562B7}"/>
+                <a16:creationId xmlns:a16="http://schemas.microsoft.com/office/drawing/2014/main" id="{A07257B6-24E9-40AA-8A7D-9550B404B0E9}"/>
               </a:ext>
             </a:extLst>
           </p:cNvPr>
@@ -4887,7 +4887,7 @@
           <p:cNvPr id="17" name="text-24">
             <a:extLst xmlns:a="http://schemas.openxmlformats.org/drawingml/2006/main">
               <a:ext uri="{FF2B5EF4-FFF2-40B4-BE49-F238E27FC236}">
-                <a16:creationId xmlns:a16="http://schemas.microsoft.com/office/drawing/2014/main" id="{66F80F37-A348-4AAF-B2B7-832728CCA73A}"/>
+                <a16:creationId xmlns:a16="http://schemas.microsoft.com/office/drawing/2014/main" id="{531779E4-B63C-4C4D-AF60-F7D4546B3BA0}"/>
               </a:ext>
             </a:extLst>
           </p:cNvPr>
@@ -4955,7 +4955,7 @@
           <p:cNvPr id="18" name="text-25">
             <a:extLst xmlns:a="http://schemas.openxmlformats.org/drawingml/2006/main">
               <a:ext uri="{FF2B5EF4-FFF2-40B4-BE49-F238E27FC236}">
-                <a16:creationId xmlns:a16="http://schemas.microsoft.com/office/drawing/2014/main" id="{C37EA7BA-1F0A-4F4B-9BD1-786012367DC3}"/>
+                <a16:creationId xmlns:a16="http://schemas.microsoft.com/office/drawing/2014/main" id="{0426C22C-BBF1-42A4-956F-F80B93377E13}"/>
               </a:ext>
             </a:extLst>
           </p:cNvPr>
@@ -5021,7 +5021,7 @@
     </p:spTree>
     <p:extLst>
       <p:ext uri="{BB962C8B-B14F-4D97-AF65-F5344CB8AC3E}">
-        <p14:creationId xmlns:p14="http://schemas.microsoft.com/office/powerpoint/2010/main" val="1800666159"/>
+        <p14:creationId xmlns:p14="http://schemas.microsoft.com/office/powerpoint/2010/main" val="918416423"/>
       </p:ext>
     </p:extLst>
   </p:cSld>
@@ -5047,74 +5047,12 @@
       <p:grpSpPr>
         <a:xfrm xmlns:a="http://schemas.openxmlformats.org/drawingml/2006/main"/>
       </p:grpSpPr>
-      <p:cxnSp>
-        <p:nvCxnSpPr>
-          <p:cNvPr id="16" name="">
+      <p:sp>
+        <p:nvSpPr>
+          <p:cNvPr id="15" name="text-26">
             <a:extLst xmlns:a="http://schemas.openxmlformats.org/drawingml/2006/main">
               <a:ext uri="{FF2B5EF4-FFF2-40B4-BE49-F238E27FC236}">
-                <a16:creationId xmlns:a16="http://schemas.microsoft.com/office/drawing/2014/main" id="{6CD2D1E1-00CF-4E44-B706-CA0524A724C4}"/>
-              </a:ext>
-            </a:extLst>
-          </p:cNvPr>
-          <p:cNvCxnSpPr>
-            <a:stCxn xmlns:a="http://schemas.openxmlformats.org/drawingml/2006/main" id="9" idx="3"/>
-            <a:endCxn xmlns:a="http://schemas.openxmlformats.org/drawingml/2006/main" id="12" idx="1"/>
-          </p:cNvCxnSpPr>
-          <p:nvPr/>
-        </p:nvCxnSpPr>
-        <p:spPr>
-          <a:xfrm xmlns:a="http://schemas.openxmlformats.org/drawingml/2006/main">
-            <a:off x="7620000" y="3614738"/>
-            <a:ext cx="533400" cy="0"/>
-          </a:xfrm>
-          <a:prstGeom xmlns:a="http://schemas.openxmlformats.org/drawingml/2006/main" prst="straightConnector1">
-            <a:avLst/>
-          </a:prstGeom>
-          <a:ln xmlns:a="http://schemas.openxmlformats.org/drawingml/2006/main" w="28575">
-            <a:solidFill>
-              <a:srgbClr val="29784B"/>
-            </a:solidFill>
-            <a:tailEnd type="triangle" w="med" len="med"/>
-          </a:ln>
-        </p:spPr>
-      </p:cxnSp>
-      <p:cxnSp>
-        <p:nvCxnSpPr>
-          <p:cNvPr id="15" name="">
-            <a:extLst xmlns:a="http://schemas.openxmlformats.org/drawingml/2006/main">
-              <a:ext uri="{FF2B5EF4-FFF2-40B4-BE49-F238E27FC236}">
-                <a16:creationId xmlns:a16="http://schemas.microsoft.com/office/drawing/2014/main" id="{D24D0859-954B-45EF-9217-829288F2E69B}"/>
-              </a:ext>
-            </a:extLst>
-          </p:cNvPr>
-          <p:cNvCxnSpPr>
-            <a:stCxn xmlns:a="http://schemas.openxmlformats.org/drawingml/2006/main" id="6" idx="3"/>
-            <a:endCxn xmlns:a="http://schemas.openxmlformats.org/drawingml/2006/main" id="9" idx="1"/>
-          </p:cNvCxnSpPr>
-          <p:nvPr/>
-        </p:nvCxnSpPr>
-        <p:spPr>
-          <a:xfrm xmlns:a="http://schemas.openxmlformats.org/drawingml/2006/main">
-            <a:off x="3848100" y="3614738"/>
-            <a:ext cx="533400" cy="0"/>
-          </a:xfrm>
-          <a:prstGeom xmlns:a="http://schemas.openxmlformats.org/drawingml/2006/main" prst="straightConnector1">
-            <a:avLst/>
-          </a:prstGeom>
-          <a:ln xmlns:a="http://schemas.openxmlformats.org/drawingml/2006/main" w="28575">
-            <a:solidFill>
-              <a:srgbClr val="29784B"/>
-            </a:solidFill>
-            <a:tailEnd type="triangle" w="med" len="med"/>
-          </a:ln>
-        </p:spPr>
-      </p:cxnSp>
-      <p:sp>
-        <p:nvSpPr>
-          <p:cNvPr id="18" name="text-26">
-            <a:extLst xmlns:a="http://schemas.openxmlformats.org/drawingml/2006/main">
-              <a:ext uri="{FF2B5EF4-FFF2-40B4-BE49-F238E27FC236}">
-                <a16:creationId xmlns:a16="http://schemas.microsoft.com/office/drawing/2014/main" id="{DD44CE71-69FE-41E0-B88A-E7361B12BE56}"/>
+                <a16:creationId xmlns:a16="http://schemas.microsoft.com/office/drawing/2014/main" id="{DA740DF1-5431-4615-8242-9BF465E44C99}"/>
               </a:ext>
             </a:extLst>
           </p:cNvPr>
@@ -5172,7 +5110,7 @@
                 <a:ea typeface="Arial"/>
                 <a:cs typeface="Arial"/>
               </a:rPr>
-              <a:t>HOW THE APP WORKS</a:t>
+              <a:t>THE COURT EVIDENCE GAP</a:t>
             </a:r>
           </a:p>
         </p:txBody>
@@ -5182,7 +5120,7 @@
           <p:cNvPr id="2" name="text-27">
             <a:extLst xmlns:a="http://schemas.openxmlformats.org/drawingml/2006/main">
               <a:ext uri="{FF2B5EF4-FFF2-40B4-BE49-F238E27FC236}">
-                <a16:creationId xmlns:a16="http://schemas.microsoft.com/office/drawing/2014/main" id="{8B86660E-C257-4D92-90A1-1FBDB638D9B1}"/>
+                <a16:creationId xmlns:a16="http://schemas.microsoft.com/office/drawing/2014/main" id="{B09B7401-AAD3-4D3C-821F-5661144BB15F}"/>
               </a:ext>
             </a:extLst>
           </p:cNvPr>
@@ -5240,7 +5178,7 @@
                 <a:ea typeface="Arial"/>
                 <a:cs typeface="Arial"/>
               </a:rPr>
-              <a:t>The complaint and accountability journey</a:t>
+              <a:t>Civic groups need stronger evidence</a:t>
             </a:r>
           </a:p>
         </p:txBody>
@@ -5250,7 +5188,7 @@
           <p:cNvPr id="3" name="frame-28">
             <a:extLst xmlns:a="http://schemas.openxmlformats.org/drawingml/2006/main">
               <a:ext uri="{FF2B5EF4-FFF2-40B4-BE49-F238E27FC236}">
-                <a16:creationId xmlns:a16="http://schemas.microsoft.com/office/drawing/2014/main" id="{DAEFF060-705C-4264-8DD7-E42D49A7B8D2}"/>
+                <a16:creationId xmlns:a16="http://schemas.microsoft.com/office/drawing/2014/main" id="{B253CDFF-5B31-4453-BDFB-77239403BE39}"/>
               </a:ext>
             </a:extLst>
           </p:cNvPr>
@@ -5280,7 +5218,7 @@
           <p:cNvPr id="4" name="text-29">
             <a:extLst xmlns:a="http://schemas.openxmlformats.org/drawingml/2006/main">
               <a:ext uri="{FF2B5EF4-FFF2-40B4-BE49-F238E27FC236}">
-                <a16:creationId xmlns:a16="http://schemas.microsoft.com/office/drawing/2014/main" id="{E5BAAF86-11EC-453F-8188-152BA1BECC86}"/>
+                <a16:creationId xmlns:a16="http://schemas.microsoft.com/office/drawing/2014/main" id="{FF3290E0-CAFF-4BFB-A638-BE13C5D426CB}"/>
               </a:ext>
             </a:extLst>
           </p:cNvPr>
@@ -5348,7 +5286,7 @@
           <p:cNvPr id="5" name="text-30">
             <a:extLst xmlns:a="http://schemas.openxmlformats.org/drawingml/2006/main">
               <a:ext uri="{FF2B5EF4-FFF2-40B4-BE49-F238E27FC236}">
-                <a16:creationId xmlns:a16="http://schemas.microsoft.com/office/drawing/2014/main" id="{74C91043-B368-42A3-92C5-7F1D1B040917}"/>
+                <a16:creationId xmlns:a16="http://schemas.microsoft.com/office/drawing/2014/main" id="{556DA948-67F3-4041-B046-AEB2288AAEFF}"/>
               </a:ext>
             </a:extLst>
           </p:cNvPr>
@@ -5413,10 +5351,10 @@
       </p:sp>
       <p:sp>
         <p:nvSpPr>
-          <p:cNvPr id="6" name="frame-31">
+          <p:cNvPr id="6" name="text-31">
             <a:extLst xmlns:a="http://schemas.openxmlformats.org/drawingml/2006/main">
               <a:ext uri="{FF2B5EF4-FFF2-40B4-BE49-F238E27FC236}">
-                <a16:creationId xmlns:a16="http://schemas.microsoft.com/office/drawing/2014/main" id="{8E4EFDE1-9F3F-472E-840B-206B386E47BA}"/>
+                <a16:creationId xmlns:a16="http://schemas.microsoft.com/office/drawing/2014/main" id="{799730BE-BA64-411C-8306-EDDD82012500}"/>
               </a:ext>
             </a:extLst>
           </p:cNvPr>
@@ -5427,28 +5365,87 @@
         </p:nvSpPr>
         <p:spPr>
           <a:xfrm xmlns:a="http://schemas.openxmlformats.org/drawingml/2006/main">
-            <a:off x="609600" y="2238375"/>
-            <a:ext cx="3238500" cy="2752725"/>
+            <a:off x="609600" y="1943100"/>
+            <a:ext cx="10972800" cy="866775"/>
           </a:xfrm>
           <a:prstGeom xmlns:a="http://schemas.openxmlformats.org/drawingml/2006/main" prst="rect">
             <a:avLst/>
           </a:prstGeom>
-          <a:solidFill xmlns:a="http://schemas.openxmlformats.org/drawingml/2006/main">
-            <a:srgbClr val="FFFFFF"/>
-          </a:solidFill>
-          <a:ln xmlns:a="http://schemas.openxmlformats.org/drawingml/2006/main" w="14288">
-            <a:solidFill>
-              <a:srgbClr val="D5DED4"/>
-            </a:solidFill>
+          <a:noFill xmlns:a="http://schemas.openxmlformats.org/drawingml/2006/main"/>
+          <a:ln xmlns:a="http://schemas.openxmlformats.org/drawingml/2006/main" w="0">
+            <a:noFill/>
           </a:ln>
         </p:spPr>
+        <p:txBody>
+          <a:bodyPr xmlns:a="http://schemas.openxmlformats.org/drawingml/2006/main" wrap="square" lIns="0" tIns="0" rIns="0" bIns="0" anchor="t">
+            <a:noAutofit/>
+          </a:bodyPr>
+          <a:lstStyle xmlns:a="http://schemas.openxmlformats.org/drawingml/2006/main">
+            <a:defPPr algn="l">
+              <a:defRPr sz="2025" b="0">
+                <a:solidFill>
+                  <a:srgbClr val="54655C"/>
+                </a:solidFill>
+                <a:latin typeface="Arial"/>
+                <a:ea typeface="Arial"/>
+                <a:cs typeface="Arial"/>
+              </a:defRPr>
+            </a:defPPr>
+          </a:lstStyle>
+          <a:p xmlns:a="http://schemas.openxmlformats.org/drawingml/2006/main">
+            <a:pPr algn="l">
+              <a:defRPr sz="2025" b="0">
+                <a:solidFill>
+                  <a:srgbClr val="54655C"/>
+                </a:solidFill>
+                <a:latin typeface="Arial"/>
+                <a:ea typeface="Arial"/>
+                <a:cs typeface="Arial"/>
+              </a:defRPr>
+            </a:pPr>
+            <a:r>
+              <a:rPr sz="2025" b="0">
+                <a:solidFill>
+                  <a:srgbClr val="54655C"/>
+                </a:solidFill>
+                <a:latin typeface="Arial"/>
+                <a:ea typeface="Arial"/>
+                <a:cs typeface="Arial"/>
+              </a:rPr>
+              <a:t>Civic organisations often lack organised evidence to support a case in court.</a:t>
+            </a:r>
+          </a:p>
+          <a:p xmlns:a="http://schemas.openxmlformats.org/drawingml/2006/main">
+            <a:pPr algn="l">
+              <a:defRPr sz="2025" b="0">
+                <a:solidFill>
+                  <a:srgbClr val="54655C"/>
+                </a:solidFill>
+                <a:latin typeface="Arial"/>
+                <a:ea typeface="Arial"/>
+                <a:cs typeface="Arial"/>
+              </a:defRPr>
+            </a:pPr>
+            <a:r>
+              <a:rPr sz="2025" b="0">
+                <a:solidFill>
+                  <a:srgbClr val="54655C"/>
+                </a:solidFill>
+                <a:latin typeface="Arial"/>
+                <a:ea typeface="Arial"/>
+                <a:cs typeface="Arial"/>
+              </a:rPr>
+              <a:t>Scattered photos and undocumented follow-up make escalation harder.</a:t>
+            </a:r>
+          </a:p>
+        </p:txBody>
       </p:sp>
       <p:sp>
         <p:nvSpPr>
           <p:cNvPr id="7" name="text-32">
             <a:extLst xmlns:a="http://schemas.openxmlformats.org/drawingml/2006/main">
               <a:ext uri="{FF2B5EF4-FFF2-40B4-BE49-F238E27FC236}">
-                <a16:creationId xmlns:a16="http://schemas.microsoft.com/office/drawing/2014/main" id="{0C503F84-96FC-4969-A22F-D5470C5DC979}"/>
+                <a16:creationId xmlns:a16="http://schemas.microsoft.com/office/drawing/2014/main" id="{FD6C2E50-8945-4EF4-92BC-FD15AA562445}"/>
               </a:ext>
             </a:extLst>
           </p:cNvPr>
@@ -5459,8 +5456,8 @@
         </p:nvSpPr>
         <p:spPr>
           <a:xfrm xmlns:a="http://schemas.openxmlformats.org/drawingml/2006/main">
-            <a:off x="819150" y="2486025"/>
-            <a:ext cx="2819400" cy="466725"/>
+            <a:off x="609600" y="3209925"/>
+            <a:ext cx="3267075" cy="695325"/>
           </a:xfrm>
           <a:prstGeom xmlns:a="http://schemas.openxmlformats.org/drawingml/2006/main" prst="rect">
             <a:avLst/>
@@ -5506,7 +5503,7 @@
                 <a:ea typeface="Arial"/>
                 <a:cs typeface="Arial"/>
               </a:rPr>
-              <a:t>Report</a:t>
+              <a:t>Citizen evidence</a:t>
             </a:r>
           </a:p>
         </p:txBody>
@@ -5516,7 +5513,7 @@
           <p:cNvPr id="8" name="text-33">
             <a:extLst xmlns:a="http://schemas.openxmlformats.org/drawingml/2006/main">
               <a:ext uri="{FF2B5EF4-FFF2-40B4-BE49-F238E27FC236}">
-                <a16:creationId xmlns:a16="http://schemas.microsoft.com/office/drawing/2014/main" id="{B452F016-3E1C-425B-995A-EDC44BE6ABCD}"/>
+                <a16:creationId xmlns:a16="http://schemas.microsoft.com/office/drawing/2014/main" id="{356F1963-CE4D-4A0E-9052-7062CBCB8653}"/>
               </a:ext>
             </a:extLst>
           </p:cNvPr>
@@ -5527,8 +5524,8 @@
         </p:nvSpPr>
         <p:spPr>
           <a:xfrm xmlns:a="http://schemas.openxmlformats.org/drawingml/2006/main">
-            <a:off x="819150" y="3171825"/>
-            <a:ext cx="2819400" cy="1581150"/>
+            <a:off x="609600" y="4105275"/>
+            <a:ext cx="3267075" cy="1381125"/>
           </a:xfrm>
           <a:prstGeom xmlns:a="http://schemas.openxmlformats.org/drawingml/2006/main" prst="rect">
             <a:avLst/>
@@ -5574,7 +5571,7 @@
                 <a:ea typeface="Arial"/>
                 <a:cs typeface="Arial"/>
               </a:rPr>
-              <a:t>Select a concern</a:t>
+              <a:t>Photos and recordings</a:t>
             </a:r>
           </a:p>
           <a:p xmlns:a="http://schemas.openxmlformats.org/drawingml/2006/main">
@@ -5597,7 +5594,7 @@
                 <a:ea typeface="Arial"/>
                 <a:cs typeface="Arial"/>
               </a:rPr>
-              <a:t>Capture evidence</a:t>
+              <a:t>Location and capture time</a:t>
             </a:r>
           </a:p>
           <a:p xmlns:a="http://schemas.openxmlformats.org/drawingml/2006/main">
@@ -5620,7 +5617,7 @@
                 <a:ea typeface="Arial"/>
                 <a:cs typeface="Arial"/>
               </a:rPr>
-              <a:t>AI prepares a draft</a:t>
+              <a:t>Complaint records</a:t>
             </a:r>
           </a:p>
           <a:p xmlns:a="http://schemas.openxmlformats.org/drawingml/2006/main">
@@ -5643,17 +5640,17 @@
                 <a:ea typeface="Arial"/>
                 <a:cs typeface="Arial"/>
               </a:rPr>
-              <a:t>Review and send</a:t>
+              <a:t>Follow-up photographs</a:t>
             </a:r>
           </a:p>
         </p:txBody>
       </p:sp>
       <p:sp>
         <p:nvSpPr>
-          <p:cNvPr id="9" name="frame-34">
+          <p:cNvPr id="9" name="text-34">
             <a:extLst xmlns:a="http://schemas.openxmlformats.org/drawingml/2006/main">
               <a:ext uri="{FF2B5EF4-FFF2-40B4-BE49-F238E27FC236}">
-                <a16:creationId xmlns:a16="http://schemas.microsoft.com/office/drawing/2014/main" id="{7584EAD9-A562-4B42-9588-8EEC5B3574F5}"/>
+                <a16:creationId xmlns:a16="http://schemas.microsoft.com/office/drawing/2014/main" id="{9771F6D3-6910-4812-A394-4931BD843881}"/>
               </a:ext>
             </a:extLst>
           </p:cNvPr>
@@ -5664,40 +5661,8 @@
         </p:nvSpPr>
         <p:spPr>
           <a:xfrm xmlns:a="http://schemas.openxmlformats.org/drawingml/2006/main">
-            <a:off x="4381500" y="2238375"/>
-            <a:ext cx="3238500" cy="2752725"/>
-          </a:xfrm>
-          <a:prstGeom xmlns:a="http://schemas.openxmlformats.org/drawingml/2006/main" prst="rect">
-            <a:avLst/>
-          </a:prstGeom>
-          <a:solidFill xmlns:a="http://schemas.openxmlformats.org/drawingml/2006/main">
-            <a:srgbClr val="FFFFFF"/>
-          </a:solidFill>
-          <a:ln xmlns:a="http://schemas.openxmlformats.org/drawingml/2006/main" w="14288">
-            <a:solidFill>
-              <a:srgbClr val="D5DED4"/>
-            </a:solidFill>
-          </a:ln>
-        </p:spPr>
-      </p:sp>
-      <p:sp>
-        <p:nvSpPr>
-          <p:cNvPr id="10" name="text-35">
-            <a:extLst xmlns:a="http://schemas.openxmlformats.org/drawingml/2006/main">
-              <a:ext uri="{FF2B5EF4-FFF2-40B4-BE49-F238E27FC236}">
-                <a16:creationId xmlns:a16="http://schemas.microsoft.com/office/drawing/2014/main" id="{640F6B1B-07AF-469C-B19F-2D5FCEFAE23F}"/>
-              </a:ext>
-            </a:extLst>
-          </p:cNvPr>
-          <p:cNvSpPr>
-            <a:spLocks xmlns:a="http://schemas.openxmlformats.org/drawingml/2006/main" noGrp="1"/>
-          </p:cNvSpPr>
-          <p:nvPr/>
-        </p:nvSpPr>
-        <p:spPr>
-          <a:xfrm xmlns:a="http://schemas.openxmlformats.org/drawingml/2006/main">
-            <a:off x="4591050" y="2486025"/>
-            <a:ext cx="2819400" cy="466725"/>
+            <a:off x="4381500" y="3209925"/>
+            <a:ext cx="3267075" cy="695325"/>
           </a:xfrm>
           <a:prstGeom xmlns:a="http://schemas.openxmlformats.org/drawingml/2006/main" prst="rect">
             <a:avLst/>
@@ -5743,17 +5708,17 @@
                 <a:ea typeface="Arial"/>
                 <a:cs typeface="Arial"/>
               </a:rPr>
-              <a:t>Make visible</a:t>
+              <a:t>An organised case</a:t>
             </a:r>
           </a:p>
         </p:txBody>
       </p:sp>
       <p:sp>
         <p:nvSpPr>
-          <p:cNvPr id="11" name="text-36">
+          <p:cNvPr id="10" name="text-35">
             <a:extLst xmlns:a="http://schemas.openxmlformats.org/drawingml/2006/main">
               <a:ext uri="{FF2B5EF4-FFF2-40B4-BE49-F238E27FC236}">
-                <a16:creationId xmlns:a16="http://schemas.microsoft.com/office/drawing/2014/main" id="{A7F4F7FA-63A3-4636-B9F9-A93D567C5582}"/>
+                <a16:creationId xmlns:a16="http://schemas.microsoft.com/office/drawing/2014/main" id="{A6825E0D-4057-45CE-8BD8-B6A84A8520BD}"/>
               </a:ext>
             </a:extLst>
           </p:cNvPr>
@@ -5764,8 +5729,8 @@
         </p:nvSpPr>
         <p:spPr>
           <a:xfrm xmlns:a="http://schemas.openxmlformats.org/drawingml/2006/main">
-            <a:off x="4591050" y="3171825"/>
-            <a:ext cx="2819400" cy="1581150"/>
+            <a:off x="4381500" y="4105275"/>
+            <a:ext cx="3267075" cy="1381125"/>
           </a:xfrm>
           <a:prstGeom xmlns:a="http://schemas.openxmlformats.org/drawingml/2006/main" prst="rect">
             <a:avLst/>
@@ -5811,7 +5776,7 @@
                 <a:ea typeface="Arial"/>
                 <a:cs typeface="Arial"/>
               </a:rPr>
-              <a:t>Save the report</a:t>
+              <a:t>Connect related concerns</a:t>
             </a:r>
           </a:p>
           <a:p xmlns:a="http://schemas.openxmlformats.org/drawingml/2006/main">
@@ -5834,7 +5799,7 @@
                 <a:ea typeface="Arial"/>
                 <a:cs typeface="Arial"/>
               </a:rPr>
-              <a:t>Open its map location</a:t>
+              <a:t>Document continuing issues</a:t>
             </a:r>
           </a:p>
           <a:p xmlns:a="http://schemas.openxmlformats.org/drawingml/2006/main">
@@ -5857,17 +5822,40 @@
                 <a:ea typeface="Arial"/>
                 <a:cs typeface="Arial"/>
               </a:rPr>
-              <a:t>See nearby concerns</a:t>
+              <a:t>Review the evidence</a:t>
+            </a:r>
+          </a:p>
+          <a:p xmlns:a="http://schemas.openxmlformats.org/drawingml/2006/main">
+            <a:pPr algn="l">
+              <a:defRPr sz="1875" b="0">
+                <a:solidFill>
+                  <a:srgbClr val="183C2F"/>
+                </a:solidFill>
+                <a:latin typeface="Arial"/>
+                <a:ea typeface="Arial"/>
+                <a:cs typeface="Arial"/>
+              </a:defRPr>
+            </a:pPr>
+            <a:r>
+              <a:rPr sz="1875" b="0">
+                <a:solidFill>
+                  <a:srgbClr val="183C2F"/>
+                </a:solidFill>
+                <a:latin typeface="Arial"/>
+                <a:ea typeface="Arial"/>
+                <a:cs typeface="Arial"/>
+              </a:rPr>
+              <a:t>with legal support</a:t>
             </a:r>
           </a:p>
         </p:txBody>
       </p:sp>
       <p:sp>
         <p:nvSpPr>
-          <p:cNvPr id="12" name="frame-37">
+          <p:cNvPr id="11" name="text-36">
             <a:extLst xmlns:a="http://schemas.openxmlformats.org/drawingml/2006/main">
               <a:ext uri="{FF2B5EF4-FFF2-40B4-BE49-F238E27FC236}">
-                <a16:creationId xmlns:a16="http://schemas.microsoft.com/office/drawing/2014/main" id="{DE5671EE-31B4-4C03-8B75-78AA97DCE048}"/>
+                <a16:creationId xmlns:a16="http://schemas.microsoft.com/office/drawing/2014/main" id="{97436444-8AEB-419B-9B5C-A772A0616F4C}"/>
               </a:ext>
             </a:extLst>
           </p:cNvPr>
@@ -5878,40 +5866,8 @@
         </p:nvSpPr>
         <p:spPr>
           <a:xfrm xmlns:a="http://schemas.openxmlformats.org/drawingml/2006/main">
-            <a:off x="8153400" y="2238375"/>
-            <a:ext cx="3238500" cy="2752725"/>
-          </a:xfrm>
-          <a:prstGeom xmlns:a="http://schemas.openxmlformats.org/drawingml/2006/main" prst="rect">
-            <a:avLst/>
-          </a:prstGeom>
-          <a:solidFill xmlns:a="http://schemas.openxmlformats.org/drawingml/2006/main">
-            <a:srgbClr val="FFFFFF"/>
-          </a:solidFill>
-          <a:ln xmlns:a="http://schemas.openxmlformats.org/drawingml/2006/main" w="14288">
-            <a:solidFill>
-              <a:srgbClr val="D5DED4"/>
-            </a:solidFill>
-          </a:ln>
-        </p:spPr>
-      </p:sp>
-      <p:sp>
-        <p:nvSpPr>
-          <p:cNvPr id="13" name="text-38">
-            <a:extLst xmlns:a="http://schemas.openxmlformats.org/drawingml/2006/main">
-              <a:ext uri="{FF2B5EF4-FFF2-40B4-BE49-F238E27FC236}">
-                <a16:creationId xmlns:a16="http://schemas.microsoft.com/office/drawing/2014/main" id="{FFE86EE5-1A35-4D14-AF75-AFBA507116FC}"/>
-              </a:ext>
-            </a:extLst>
-          </p:cNvPr>
-          <p:cNvSpPr>
-            <a:spLocks xmlns:a="http://schemas.openxmlformats.org/drawingml/2006/main" noGrp="1"/>
-          </p:cNvSpPr>
-          <p:nvPr/>
-        </p:nvSpPr>
-        <p:spPr>
-          <a:xfrm xmlns:a="http://schemas.openxmlformats.org/drawingml/2006/main">
-            <a:off x="8362950" y="2486025"/>
-            <a:ext cx="2819400" cy="466725"/>
+            <a:off x="8153400" y="3209925"/>
+            <a:ext cx="3267075" cy="695325"/>
           </a:xfrm>
           <a:prstGeom xmlns:a="http://schemas.openxmlformats.org/drawingml/2006/main" prst="rect">
             <a:avLst/>
@@ -5957,17 +5913,17 @@
                 <a:ea typeface="Arial"/>
                 <a:cs typeface="Arial"/>
               </a:rPr>
-              <a:t>Follow up</a:t>
+              <a:t>Court accountability</a:t>
             </a:r>
           </a:p>
         </p:txBody>
       </p:sp>
       <p:sp>
         <p:nvSpPr>
-          <p:cNvPr id="14" name="text-39">
+          <p:cNvPr id="12" name="text-37">
             <a:extLst xmlns:a="http://schemas.openxmlformats.org/drawingml/2006/main">
               <a:ext uri="{FF2B5EF4-FFF2-40B4-BE49-F238E27FC236}">
-                <a16:creationId xmlns:a16="http://schemas.microsoft.com/office/drawing/2014/main" id="{55B6AE7A-B6B4-41DF-B27B-C21BEB43E5AC}"/>
+                <a16:creationId xmlns:a16="http://schemas.microsoft.com/office/drawing/2014/main" id="{089B2AD2-2C0C-42C6-8395-C4EEFE77546F}"/>
               </a:ext>
             </a:extLst>
           </p:cNvPr>
@@ -5978,8 +5934,8 @@
         </p:nvSpPr>
         <p:spPr>
           <a:xfrm xmlns:a="http://schemas.openxmlformats.org/drawingml/2006/main">
-            <a:off x="8362950" y="3171825"/>
-            <a:ext cx="2819400" cy="1581150"/>
+            <a:off x="8153400" y="4105275"/>
+            <a:ext cx="3267075" cy="1381125"/>
           </a:xfrm>
           <a:prstGeom xmlns:a="http://schemas.openxmlformats.org/drawingml/2006/main" prst="rect">
             <a:avLst/>
@@ -6025,7 +5981,7 @@
                 <a:ea typeface="Arial"/>
                 <a:cs typeface="Arial"/>
               </a:rPr>
-              <a:t>Add a follow-up photo</a:t>
+              <a:t>Use supporting records</a:t>
             </a:r>
           </a:p>
           <a:p xmlns:a="http://schemas.openxmlformats.org/drawingml/2006/main">
@@ -6048,7 +6004,7 @@
                 <a:ea typeface="Arial"/>
                 <a:cs typeface="Arial"/>
               </a:rPr>
-              <a:t>for supported cases</a:t>
+              <a:t>in legal proceedings</a:t>
             </a:r>
           </a:p>
           <a:p xmlns:a="http://schemas.openxmlformats.org/drawingml/2006/main">
@@ -6071,7 +6027,7 @@
                 <a:ea typeface="Arial"/>
                 <a:cs typeface="Arial"/>
               </a:rPr>
-              <a:t>Document change</a:t>
+              <a:t>Seek official action</a:t>
             </a:r>
           </a:p>
           <a:p xmlns:a="http://schemas.openxmlformats.org/drawingml/2006/main">
@@ -6094,17 +6050,17 @@
                 <a:ea typeface="Arial"/>
                 <a:cs typeface="Arial"/>
               </a:rPr>
-              <a:t>Escalate if unresolved</a:t>
+              <a:t>and accountability</a:t>
             </a:r>
           </a:p>
         </p:txBody>
       </p:sp>
       <p:sp>
         <p:nvSpPr>
-          <p:cNvPr id="17" name="text-40">
+          <p:cNvPr id="13" name="text-38">
             <a:extLst xmlns:a="http://schemas.openxmlformats.org/drawingml/2006/main">
               <a:ext uri="{FF2B5EF4-FFF2-40B4-BE49-F238E27FC236}">
-                <a16:creationId xmlns:a16="http://schemas.microsoft.com/office/drawing/2014/main" id="{C5AB7524-1AC2-4514-B2AD-6F5C8DBED887}"/>
+                <a16:creationId xmlns:a16="http://schemas.microsoft.com/office/drawing/2014/main" id="{BCCC1E51-84F1-41A3-B468-9F75E19FE816}"/>
               </a:ext>
             </a:extLst>
           </p:cNvPr>
@@ -6115,8 +6071,8 @@
         </p:nvSpPr>
         <p:spPr>
           <a:xfrm xmlns:a="http://schemas.openxmlformats.org/drawingml/2006/main">
-            <a:off x="609600" y="5543550"/>
-            <a:ext cx="10972800" cy="476250"/>
+            <a:off x="609600" y="5638800"/>
+            <a:ext cx="10972800" cy="381000"/>
           </a:xfrm>
           <a:prstGeom xmlns:a="http://schemas.openxmlformats.org/drawingml/2006/main" prst="rect">
             <a:avLst/>
@@ -6132,7 +6088,7 @@
           </a:bodyPr>
           <a:lstStyle xmlns:a="http://schemas.openxmlformats.org/drawingml/2006/main">
             <a:defPPr algn="l">
-              <a:defRPr sz="2250" b="1">
+              <a:defRPr sz="2025" b="1">
                 <a:solidFill>
                   <a:srgbClr val="29784B"/>
                 </a:solidFill>
@@ -6144,7 +6100,7 @@
           </a:lstStyle>
           <a:p xmlns:a="http://schemas.openxmlformats.org/drawingml/2006/main">
             <a:pPr algn="l">
-              <a:defRPr sz="2250" b="1">
+              <a:defRPr sz="2025" b="1">
                 <a:solidFill>
                   <a:srgbClr val="29784B"/>
                 </a:solidFill>
@@ -6154,7 +6110,7 @@
               </a:defRPr>
             </a:pPr>
             <a:r>
-              <a:rPr sz="2250" b="1">
+              <a:rPr sz="2025" b="1">
                 <a:solidFill>
                   <a:srgbClr val="29784B"/>
                 </a:solidFill>
@@ -6162,7 +6118,75 @@
                 <a:ea typeface="Arial"/>
                 <a:cs typeface="Arial"/>
               </a:rPr>
-              <a:t>Each step adds context to the citizen’s evidence record</a:t>
+              <a:t>Collected citizen evidence can help civic groups substantiate their concerns</a:t>
+            </a:r>
+          </a:p>
+        </p:txBody>
+      </p:sp>
+      <p:sp>
+        <p:nvSpPr>
+          <p:cNvPr id="14" name="text-39">
+            <a:extLst xmlns:a="http://schemas.openxmlformats.org/drawingml/2006/main">
+              <a:ext uri="{FF2B5EF4-FFF2-40B4-BE49-F238E27FC236}">
+                <a16:creationId xmlns:a16="http://schemas.microsoft.com/office/drawing/2014/main" id="{D866DF34-477F-400A-A8B9-7DE1A15BF293}"/>
+              </a:ext>
+            </a:extLst>
+          </p:cNvPr>
+          <p:cNvSpPr>
+            <a:spLocks xmlns:a="http://schemas.openxmlformats.org/drawingml/2006/main" noGrp="1"/>
+          </p:cNvSpPr>
+          <p:nvPr/>
+        </p:nvSpPr>
+        <p:spPr>
+          <a:xfrm xmlns:a="http://schemas.openxmlformats.org/drawingml/2006/main">
+            <a:off x="609600" y="6067425"/>
+            <a:ext cx="10972800" cy="219075"/>
+          </a:xfrm>
+          <a:prstGeom xmlns:a="http://schemas.openxmlformats.org/drawingml/2006/main" prst="rect">
+            <a:avLst/>
+          </a:prstGeom>
+          <a:noFill xmlns:a="http://schemas.openxmlformats.org/drawingml/2006/main"/>
+          <a:ln xmlns:a="http://schemas.openxmlformats.org/drawingml/2006/main" w="0">
+            <a:noFill/>
+          </a:ln>
+        </p:spPr>
+        <p:txBody>
+          <a:bodyPr xmlns:a="http://schemas.openxmlformats.org/drawingml/2006/main" wrap="square" lIns="0" tIns="0" rIns="0" bIns="0" anchor="t">
+            <a:noAutofit/>
+          </a:bodyPr>
+          <a:lstStyle xmlns:a="http://schemas.openxmlformats.org/drawingml/2006/main">
+            <a:defPPr algn="l">
+              <a:defRPr sz="1200" b="0">
+                <a:solidFill>
+                  <a:srgbClr val="54655C"/>
+                </a:solidFill>
+                <a:latin typeface="Arial"/>
+                <a:ea typeface="Arial"/>
+                <a:cs typeface="Arial"/>
+              </a:defRPr>
+            </a:defPPr>
+          </a:lstStyle>
+          <a:p xmlns:a="http://schemas.openxmlformats.org/drawingml/2006/main">
+            <a:pPr algn="l">
+              <a:defRPr sz="1200" b="0">
+                <a:solidFill>
+                  <a:srgbClr val="54655C"/>
+                </a:solidFill>
+                <a:latin typeface="Arial"/>
+                <a:ea typeface="Arial"/>
+                <a:cs typeface="Arial"/>
+              </a:defRPr>
+            </a:pPr>
+            <a:r>
+              <a:rPr sz="1200" b="0">
+                <a:solidFill>
+                  <a:srgbClr val="54655C"/>
+                </a:solidFill>
+                <a:latin typeface="Arial"/>
+                <a:ea typeface="Arial"/>
+                <a:cs typeface="Arial"/>
+              </a:rPr>
+              <a:t>Court acceptance depends on applicable evidentiary requirements and legal review.</a:t>
             </a:r>
           </a:p>
         </p:txBody>
@@ -6170,7 +6194,7 @@
     </p:spTree>
     <p:extLst>
       <p:ext uri="{BB962C8B-B14F-4D97-AF65-F5344CB8AC3E}">
-        <p14:creationId xmlns:p14="http://schemas.microsoft.com/office/powerpoint/2010/main" val="330893677"/>
+        <p14:creationId xmlns:p14="http://schemas.microsoft.com/office/powerpoint/2010/main" val="40760489"/>
       </p:ext>
     </p:extLst>
   </p:cSld>
@@ -6198,10 +6222,10 @@
       </p:grpSpPr>
       <p:sp>
         <p:nvSpPr>
-          <p:cNvPr id="15" name="text-41">
+          <p:cNvPr id="15" name="text-40">
             <a:extLst xmlns:a="http://schemas.openxmlformats.org/drawingml/2006/main">
               <a:ext uri="{FF2B5EF4-FFF2-40B4-BE49-F238E27FC236}">
-                <a16:creationId xmlns:a16="http://schemas.microsoft.com/office/drawing/2014/main" id="{F9FAE52A-DB10-4794-99BC-85AB99900F18}"/>
+                <a16:creationId xmlns:a16="http://schemas.microsoft.com/office/drawing/2014/main" id="{B8E4D8D1-596D-4E73-AB63-69DC55A6E72D}"/>
               </a:ext>
             </a:extLst>
           </p:cNvPr>
@@ -6266,10 +6290,10 @@
       </p:sp>
       <p:sp>
         <p:nvSpPr>
-          <p:cNvPr id="2" name="text-42">
+          <p:cNvPr id="2" name="text-41">
             <a:extLst xmlns:a="http://schemas.openxmlformats.org/drawingml/2006/main">
               <a:ext uri="{FF2B5EF4-FFF2-40B4-BE49-F238E27FC236}">
-                <a16:creationId xmlns:a16="http://schemas.microsoft.com/office/drawing/2014/main" id="{ED68E68F-0B1F-4EDF-9178-76777C1E1330}"/>
+                <a16:creationId xmlns:a16="http://schemas.microsoft.com/office/drawing/2014/main" id="{C29F7A66-351B-4143-B5D6-6071BCE3F2A4}"/>
               </a:ext>
             </a:extLst>
           </p:cNvPr>
@@ -6334,10 +6358,10 @@
       </p:sp>
       <p:sp>
         <p:nvSpPr>
-          <p:cNvPr id="3" name="frame-43">
+          <p:cNvPr id="3" name="frame-42">
             <a:extLst xmlns:a="http://schemas.openxmlformats.org/drawingml/2006/main">
               <a:ext uri="{FF2B5EF4-FFF2-40B4-BE49-F238E27FC236}">
-                <a16:creationId xmlns:a16="http://schemas.microsoft.com/office/drawing/2014/main" id="{20CFCB82-FD69-4FCC-AE31-BAF84BCA34F7}"/>
+                <a16:creationId xmlns:a16="http://schemas.microsoft.com/office/drawing/2014/main" id="{A304530D-4F64-48C9-B15D-401547CE286C}"/>
               </a:ext>
             </a:extLst>
           </p:cNvPr>
@@ -6364,10 +6388,10 @@
       </p:sp>
       <p:sp>
         <p:nvSpPr>
-          <p:cNvPr id="4" name="text-44">
+          <p:cNvPr id="4" name="text-43">
             <a:extLst xmlns:a="http://schemas.openxmlformats.org/drawingml/2006/main">
               <a:ext uri="{FF2B5EF4-FFF2-40B4-BE49-F238E27FC236}">
-                <a16:creationId xmlns:a16="http://schemas.microsoft.com/office/drawing/2014/main" id="{E826F0C3-8A00-4D91-B7AE-05257BFD929E}"/>
+                <a16:creationId xmlns:a16="http://schemas.microsoft.com/office/drawing/2014/main" id="{890CCBDB-C83D-4A8E-9807-CEC407739C59}"/>
               </a:ext>
             </a:extLst>
           </p:cNvPr>
@@ -6432,10 +6456,10 @@
       </p:sp>
       <p:sp>
         <p:nvSpPr>
-          <p:cNvPr id="5" name="text-45">
+          <p:cNvPr id="5" name="text-44">
             <a:extLst xmlns:a="http://schemas.openxmlformats.org/drawingml/2006/main">
               <a:ext uri="{FF2B5EF4-FFF2-40B4-BE49-F238E27FC236}">
-                <a16:creationId xmlns:a16="http://schemas.microsoft.com/office/drawing/2014/main" id="{32E8EF5E-4EBA-4312-A80E-A9457B0E2371}"/>
+                <a16:creationId xmlns:a16="http://schemas.microsoft.com/office/drawing/2014/main" id="{6C3ADA94-5C2F-4D62-ABFC-5C8E0E3E787B}"/>
               </a:ext>
             </a:extLst>
           </p:cNvPr>
@@ -6500,10 +6524,10 @@
       </p:sp>
       <p:sp>
         <p:nvSpPr>
-          <p:cNvPr id="6" name="text-46">
+          <p:cNvPr id="6" name="text-45">
             <a:extLst xmlns:a="http://schemas.openxmlformats.org/drawingml/2006/main">
               <a:ext uri="{FF2B5EF4-FFF2-40B4-BE49-F238E27FC236}">
-                <a16:creationId xmlns:a16="http://schemas.microsoft.com/office/drawing/2014/main" id="{F81962B4-2CE1-45E2-BF77-D8F52FA765A4}"/>
+                <a16:creationId xmlns:a16="http://schemas.microsoft.com/office/drawing/2014/main" id="{482A1AEF-4128-470B-847F-7E64B9F88F55}"/>
               </a:ext>
             </a:extLst>
           </p:cNvPr>
@@ -6568,10 +6592,10 @@
       </p:sp>
       <p:sp>
         <p:nvSpPr>
-          <p:cNvPr id="7" name="text-47">
+          <p:cNvPr id="7" name="text-46">
             <a:extLst xmlns:a="http://schemas.openxmlformats.org/drawingml/2006/main">
               <a:ext uri="{FF2B5EF4-FFF2-40B4-BE49-F238E27FC236}">
-                <a16:creationId xmlns:a16="http://schemas.microsoft.com/office/drawing/2014/main" id="{1A18A388-308E-4627-B887-71136E844388}"/>
+                <a16:creationId xmlns:a16="http://schemas.microsoft.com/office/drawing/2014/main" id="{641455FE-474E-4FEE-AA9C-B55BA1527BB0}"/>
               </a:ext>
             </a:extLst>
           </p:cNvPr>
@@ -6659,10 +6683,10 @@
       </p:sp>
       <p:sp>
         <p:nvSpPr>
-          <p:cNvPr id="8" name="text-48">
+          <p:cNvPr id="8" name="text-47">
             <a:extLst xmlns:a="http://schemas.openxmlformats.org/drawingml/2006/main">
               <a:ext uri="{FF2B5EF4-FFF2-40B4-BE49-F238E27FC236}">
-                <a16:creationId xmlns:a16="http://schemas.microsoft.com/office/drawing/2014/main" id="{BB0B0179-1AF5-415D-89C4-C376BB831CCC}"/>
+                <a16:creationId xmlns:a16="http://schemas.microsoft.com/office/drawing/2014/main" id="{66B62564-D545-4BE8-A7C2-FAAA3FA6DCA4}"/>
               </a:ext>
             </a:extLst>
           </p:cNvPr>
@@ -6727,10 +6751,10 @@
       </p:sp>
       <p:sp>
         <p:nvSpPr>
-          <p:cNvPr id="9" name="text-49">
+          <p:cNvPr id="9" name="text-48">
             <a:extLst xmlns:a="http://schemas.openxmlformats.org/drawingml/2006/main">
               <a:ext uri="{FF2B5EF4-FFF2-40B4-BE49-F238E27FC236}">
-                <a16:creationId xmlns:a16="http://schemas.microsoft.com/office/drawing/2014/main" id="{AC0B982C-193D-4260-8D39-BC77AC858E39}"/>
+                <a16:creationId xmlns:a16="http://schemas.microsoft.com/office/drawing/2014/main" id="{1F2A2C89-F875-477A-AE01-D1FEEA46987D}"/>
               </a:ext>
             </a:extLst>
           </p:cNvPr>
@@ -6818,10 +6842,10 @@
       </p:sp>
       <p:sp>
         <p:nvSpPr>
-          <p:cNvPr id="10" name="text-50">
+          <p:cNvPr id="10" name="text-49">
             <a:extLst xmlns:a="http://schemas.openxmlformats.org/drawingml/2006/main">
               <a:ext uri="{FF2B5EF4-FFF2-40B4-BE49-F238E27FC236}">
-                <a16:creationId xmlns:a16="http://schemas.microsoft.com/office/drawing/2014/main" id="{5EBB1F27-29E1-4F29-9CF8-5F983AED72E8}"/>
+                <a16:creationId xmlns:a16="http://schemas.microsoft.com/office/drawing/2014/main" id="{2A18DAD5-01CF-4C06-9040-2F12DE634968}"/>
               </a:ext>
             </a:extLst>
           </p:cNvPr>
@@ -6886,10 +6910,10 @@
       </p:sp>
       <p:sp>
         <p:nvSpPr>
-          <p:cNvPr id="11" name="text-51">
+          <p:cNvPr id="11" name="text-50">
             <a:extLst xmlns:a="http://schemas.openxmlformats.org/drawingml/2006/main">
               <a:ext uri="{FF2B5EF4-FFF2-40B4-BE49-F238E27FC236}">
-                <a16:creationId xmlns:a16="http://schemas.microsoft.com/office/drawing/2014/main" id="{712ACFD3-2DD6-4739-88DC-544E4824F809}"/>
+                <a16:creationId xmlns:a16="http://schemas.microsoft.com/office/drawing/2014/main" id="{4BFB8F86-3833-47B3-91F4-3C1A2F101FC7}"/>
               </a:ext>
             </a:extLst>
           </p:cNvPr>
@@ -6977,10 +7001,10 @@
       </p:sp>
       <p:sp>
         <p:nvSpPr>
-          <p:cNvPr id="12" name="text-52">
+          <p:cNvPr id="12" name="text-51">
             <a:extLst xmlns:a="http://schemas.openxmlformats.org/drawingml/2006/main">
               <a:ext uri="{FF2B5EF4-FFF2-40B4-BE49-F238E27FC236}">
-                <a16:creationId xmlns:a16="http://schemas.microsoft.com/office/drawing/2014/main" id="{7A7A24F7-1207-4A3E-B681-8810771DA9AF}"/>
+                <a16:creationId xmlns:a16="http://schemas.microsoft.com/office/drawing/2014/main" id="{4B5C8A49-CCDD-45F1-8314-41B95ED37DED}"/>
               </a:ext>
             </a:extLst>
           </p:cNvPr>
@@ -7045,10 +7069,10 @@
       </p:sp>
       <p:sp>
         <p:nvSpPr>
-          <p:cNvPr id="13" name="text-53">
+          <p:cNvPr id="13" name="text-52">
             <a:extLst xmlns:a="http://schemas.openxmlformats.org/drawingml/2006/main">
               <a:ext uri="{FF2B5EF4-FFF2-40B4-BE49-F238E27FC236}">
-                <a16:creationId xmlns:a16="http://schemas.microsoft.com/office/drawing/2014/main" id="{2995FFFE-FC0F-4825-9241-5C8A3EDB9DA5}"/>
+                <a16:creationId xmlns:a16="http://schemas.microsoft.com/office/drawing/2014/main" id="{388BFB3C-355F-4F4D-BD76-A3BE6EEF8F59}"/>
               </a:ext>
             </a:extLst>
           </p:cNvPr>
@@ -7136,10 +7160,10 @@
       </p:sp>
       <p:sp>
         <p:nvSpPr>
-          <p:cNvPr id="14" name="text-54">
+          <p:cNvPr id="14" name="text-53">
             <a:extLst xmlns:a="http://schemas.openxmlformats.org/drawingml/2006/main">
               <a:ext uri="{FF2B5EF4-FFF2-40B4-BE49-F238E27FC236}">
-                <a16:creationId xmlns:a16="http://schemas.microsoft.com/office/drawing/2014/main" id="{3E053DB0-B604-4865-876A-EE393EFA94AC}"/>
+                <a16:creationId xmlns:a16="http://schemas.microsoft.com/office/drawing/2014/main" id="{D7BAC7D2-2228-4F45-8E12-2F1A6A94C872}"/>
               </a:ext>
             </a:extLst>
           </p:cNvPr>
@@ -7228,7 +7252,7 @@
     </p:spTree>
     <p:extLst>
       <p:ext uri="{BB962C8B-B14F-4D97-AF65-F5344CB8AC3E}">
-        <p14:creationId xmlns:p14="http://schemas.microsoft.com/office/powerpoint/2010/main" val="1418174552"/>
+        <p14:creationId xmlns:p14="http://schemas.microsoft.com/office/powerpoint/2010/main" val="1847895477"/>
       </p:ext>
     </p:extLst>
   </p:cSld>

</xml_diff>